<commit_message>
Document live deployment and link the presentation demo
</commit_message>
<xml_diff>
--- a/presentation/financial_sentiment.pptx
+++ b/presentation/financial_sentiment.pptx
@@ -16304,11 +16304,11 @@
 </file>
 
 <file path=ppt/slides/slide8.xml><?xml version="1.0" encoding="utf-8"?>
-<p:sld xmlns:p="http://schemas.openxmlformats.org/presentationml/2006/main">
+<p:sld xmlns:a="http://schemas.openxmlformats.org/drawingml/2006/main" xmlns:ns2="http://schemas.microsoft.com/office/drawing/2014/main" xmlns:ns4="http://schemas.microsoft.com/office/powerpoint/2010/main" xmlns:p="http://schemas.openxmlformats.org/presentationml/2006/main" xmlns:r="http://schemas.openxmlformats.org/officeDocument/2006/relationships">
   <p:cSld>
     <p:bg>
       <p:bgPr>
-        <a:solidFill xmlns:a="http://schemas.openxmlformats.org/drawingml/2006/main">
+        <a:solidFill>
           <a:srgbClr val="FFFFFF"/>
         </a:solidFill>
       </p:bgPr>
@@ -16320,38 +16320,38 @@
         <p:nvPr/>
       </p:nvGrpSpPr>
       <p:grpSpPr>
-        <a:xfrm xmlns:a="http://schemas.openxmlformats.org/drawingml/2006/main"/>
+        <a:xfrm/>
       </p:grpSpPr>
       <p:sp>
         <p:nvSpPr>
           <p:cNvPr id="9" name="">
-            <a:extLst xmlns:a="http://schemas.openxmlformats.org/drawingml/2006/main">
+            <a:extLst>
               <a:ext uri="{FF2B5EF4-FFF2-40B4-BE49-F238E27FC236}">
-                <a16:creationId xmlns:a16="http://schemas.microsoft.com/office/drawing/2014/main" id="{41FA6588-0901-4DE2-B202-D054E891DCF2}"/>
+                <ns2:creationId id="{41FA6588-0901-4DE2-B202-D054E891DCF2}"/>
               </a:ext>
             </a:extLst>
           </p:cNvPr>
           <p:cNvSpPr>
-            <a:spLocks xmlns:a="http://schemas.openxmlformats.org/drawingml/2006/main" noGrp="1"/>
+            <a:spLocks noGrp="1"/>
           </p:cNvSpPr>
           <p:nvPr/>
         </p:nvSpPr>
         <p:spPr>
-          <a:xfrm xmlns:a="http://schemas.openxmlformats.org/drawingml/2006/main">
+          <a:xfrm>
             <a:off x="685800" y="514350"/>
             <a:ext cx="10820400" cy="800100"/>
           </a:xfrm>
-          <a:prstGeom xmlns:a="http://schemas.openxmlformats.org/drawingml/2006/main" prst="rect">
+          <a:prstGeom prst="rect">
             <a:avLst/>
           </a:prstGeom>
-          <a:noFill xmlns:a="http://schemas.openxmlformats.org/drawingml/2006/main"/>
-          <a:ln xmlns:a="http://schemas.openxmlformats.org/drawingml/2006/main" w="0">
+          <a:noFill/>
+          <a:ln w="0">
             <a:noFill/>
           </a:ln>
         </p:spPr>
         <p:txBody>
-          <a:bodyPr xmlns:a="http://schemas.openxmlformats.org/drawingml/2006/main" lIns="0" tIns="0" rIns="0" bIns="0"/>
-          <a:lstStyle xmlns:a="http://schemas.openxmlformats.org/drawingml/2006/main">
+          <a:bodyPr lIns="0" tIns="0" rIns="0" bIns="0"/>
+          <a:lstStyle>
             <a:defPPr>
               <a:defRPr sz="3225" b="1">
                 <a:solidFill>
@@ -16453,7 +16453,7 @@
               </a:defRPr>
             </a:lvl9pPr>
           </a:lstStyle>
-          <a:p xmlns:a="http://schemas.openxmlformats.org/drawingml/2006/main">
+          <a:p>
             <a:pPr>
               <a:defRPr sz="3225" b="1">
                 <a:solidFill>
@@ -16481,33 +16481,33 @@
       <p:sp>
         <p:nvSpPr>
           <p:cNvPr id="2" name="">
-            <a:extLst xmlns:a="http://schemas.openxmlformats.org/drawingml/2006/main">
+            <a:extLst>
               <a:ext uri="{FF2B5EF4-FFF2-40B4-BE49-F238E27FC236}">
-                <a16:creationId xmlns:a16="http://schemas.microsoft.com/office/drawing/2014/main" id="{68FD629A-B992-4D31-95D7-1B9D04D0BFC4}"/>
+                <ns2:creationId id="{68FD629A-B992-4D31-95D7-1B9D04D0BFC4}"/>
               </a:ext>
             </a:extLst>
           </p:cNvPr>
           <p:cNvSpPr>
-            <a:spLocks xmlns:a="http://schemas.openxmlformats.org/drawingml/2006/main" noGrp="1"/>
+            <a:spLocks noGrp="1"/>
           </p:cNvSpPr>
           <p:nvPr/>
         </p:nvSpPr>
         <p:spPr>
-          <a:xfrm xmlns:a="http://schemas.openxmlformats.org/drawingml/2006/main">
+          <a:xfrm>
             <a:off x="10972800" y="6315075"/>
             <a:ext cx="533400" cy="247650"/>
           </a:xfrm>
-          <a:prstGeom xmlns:a="http://schemas.openxmlformats.org/drawingml/2006/main" prst="rect">
+          <a:prstGeom prst="rect">
             <a:avLst/>
           </a:prstGeom>
-          <a:noFill xmlns:a="http://schemas.openxmlformats.org/drawingml/2006/main"/>
-          <a:ln xmlns:a="http://schemas.openxmlformats.org/drawingml/2006/main" w="0">
+          <a:noFill/>
+          <a:ln w="0">
             <a:noFill/>
           </a:ln>
         </p:spPr>
         <p:txBody>
-          <a:bodyPr xmlns:a="http://schemas.openxmlformats.org/drawingml/2006/main" lIns="0" tIns="0" rIns="0" bIns="0"/>
-          <a:lstStyle xmlns:a="http://schemas.openxmlformats.org/drawingml/2006/main">
+          <a:bodyPr lIns="0" tIns="0" rIns="0" bIns="0"/>
+          <a:lstStyle>
             <a:defPPr>
               <a:defRPr sz="1275" b="0">
                 <a:solidFill>
@@ -16609,7 +16609,7 @@
               </a:defRPr>
             </a:lvl9pPr>
           </a:lstStyle>
-          <a:p xmlns:a="http://schemas.openxmlformats.org/drawingml/2006/main">
+          <a:p>
             <a:pPr>
               <a:defRPr sz="1275" b="0">
                 <a:solidFill>
@@ -16637,27 +16637,27 @@
       <p:pic>
         <p:nvPicPr>
           <p:cNvPr id="3" name="">
-            <a:extLst xmlns:a="http://schemas.openxmlformats.org/drawingml/2006/main">
+            <a:extLst>
               <a:ext uri="{FF2B5EF4-FFF2-40B4-BE49-F238E27FC236}">
-                <a16:creationId xmlns:a16="http://schemas.microsoft.com/office/drawing/2014/main" id="{259C9633-79FB-45D8-9FEC-A70D02BC23CD}"/>
+                <ns2:creationId id="{259C9633-79FB-45D8-9FEC-A70D02BC23CD}"/>
               </a:ext>
             </a:extLst>
           </p:cNvPr>
           <p:cNvPicPr>
-            <a:picLocks xmlns:a="http://schemas.openxmlformats.org/drawingml/2006/main" noChangeAspect="1"/>
+            <a:picLocks noChangeAspect="1"/>
           </p:cNvPicPr>
           <p:nvPr/>
         </p:nvPicPr>
         <p:blipFill>
-          <a:blip xmlns:r="http://schemas.openxmlformats.org/officeDocument/2006/relationships" xmlns:a="http://schemas.openxmlformats.org/drawingml/2006/main" r:embed="R6b61370d64ed45e3"/>
-          <a:stretch xmlns:a="http://schemas.openxmlformats.org/drawingml/2006/main"/>
+          <a:blip r:embed="R6b61370d64ed45e3"/>
+          <a:stretch/>
         </p:blipFill>
         <p:spPr>
-          <a:xfrm xmlns:a="http://schemas.openxmlformats.org/drawingml/2006/main">
+          <a:xfrm>
             <a:off x="818294" y="1466850"/>
             <a:ext cx="3830761" cy="4419600"/>
           </a:xfrm>
-          <a:prstGeom xmlns:a="http://schemas.openxmlformats.org/drawingml/2006/main" prst="rect">
+          <a:prstGeom prst="rect">
             <a:avLst/>
           </a:prstGeom>
         </p:spPr>
@@ -16665,33 +16665,33 @@
       <p:sp>
         <p:nvSpPr>
           <p:cNvPr id="4" name="">
-            <a:extLst xmlns:a="http://schemas.openxmlformats.org/drawingml/2006/main">
+            <a:extLst>
               <a:ext uri="{FF2B5EF4-FFF2-40B4-BE49-F238E27FC236}">
-                <a16:creationId xmlns:a16="http://schemas.microsoft.com/office/drawing/2014/main" id="{89CC2282-C932-41AB-993F-89FD19E6E85A}"/>
+                <ns2:creationId id="{89CC2282-C932-41AB-993F-89FD19E6E85A}"/>
               </a:ext>
             </a:extLst>
           </p:cNvPr>
           <p:cNvSpPr>
-            <a:spLocks xmlns:a="http://schemas.openxmlformats.org/drawingml/2006/main" noGrp="1"/>
+            <a:spLocks noGrp="1"/>
           </p:cNvSpPr>
           <p:nvPr/>
         </p:nvSpPr>
         <p:spPr>
-          <a:xfrm xmlns:a="http://schemas.openxmlformats.org/drawingml/2006/main">
+          <a:xfrm>
             <a:off x="5429250" y="1714500"/>
             <a:ext cx="6076950" cy="428625"/>
           </a:xfrm>
-          <a:prstGeom xmlns:a="http://schemas.openxmlformats.org/drawingml/2006/main" prst="rect">
+          <a:prstGeom prst="rect">
             <a:avLst/>
           </a:prstGeom>
-          <a:noFill xmlns:a="http://schemas.openxmlformats.org/drawingml/2006/main"/>
-          <a:ln xmlns:a="http://schemas.openxmlformats.org/drawingml/2006/main" w="0">
+          <a:noFill/>
+          <a:ln w="0">
             <a:noFill/>
           </a:ln>
         </p:spPr>
         <p:txBody>
-          <a:bodyPr xmlns:a="http://schemas.openxmlformats.org/drawingml/2006/main" lIns="0" tIns="0" rIns="0" bIns="0"/>
-          <a:lstStyle xmlns:a="http://schemas.openxmlformats.org/drawingml/2006/main">
+          <a:bodyPr lIns="0" tIns="0" rIns="0" bIns="0"/>
+          <a:lstStyle>
             <a:defPPr>
               <a:defRPr sz="2175" b="1">
                 <a:solidFill>
@@ -16793,7 +16793,7 @@
               </a:defRPr>
             </a:lvl9pPr>
           </a:lstStyle>
-          <a:p xmlns:a="http://schemas.openxmlformats.org/drawingml/2006/main">
+          <a:p>
             <a:pPr>
               <a:defRPr sz="2175" b="1">
                 <a:solidFill>
@@ -16821,33 +16821,33 @@
       <p:sp>
         <p:nvSpPr>
           <p:cNvPr id="5" name="">
-            <a:extLst xmlns:a="http://schemas.openxmlformats.org/drawingml/2006/main">
+            <a:extLst>
               <a:ext uri="{FF2B5EF4-FFF2-40B4-BE49-F238E27FC236}">
-                <a16:creationId xmlns:a16="http://schemas.microsoft.com/office/drawing/2014/main" id="{C66D17CF-C3CF-47DA-A53A-7BEB713C7173}"/>
+                <ns2:creationId id="{C66D17CF-C3CF-47DA-A53A-7BEB713C7173}"/>
               </a:ext>
             </a:extLst>
           </p:cNvPr>
           <p:cNvSpPr>
-            <a:spLocks xmlns:a="http://schemas.openxmlformats.org/drawingml/2006/main" noGrp="1"/>
+            <a:spLocks noGrp="1"/>
           </p:cNvSpPr>
           <p:nvPr/>
         </p:nvSpPr>
         <p:spPr>
-          <a:xfrm xmlns:a="http://schemas.openxmlformats.org/drawingml/2006/main">
+          <a:xfrm>
             <a:off x="5429250" y="2190750"/>
             <a:ext cx="6076950" cy="1104900"/>
           </a:xfrm>
-          <a:prstGeom xmlns:a="http://schemas.openxmlformats.org/drawingml/2006/main" prst="rect">
+          <a:prstGeom prst="rect">
             <a:avLst/>
           </a:prstGeom>
-          <a:noFill xmlns:a="http://schemas.openxmlformats.org/drawingml/2006/main"/>
-          <a:ln xmlns:a="http://schemas.openxmlformats.org/drawingml/2006/main" w="0">
+          <a:noFill/>
+          <a:ln w="0">
             <a:noFill/>
           </a:ln>
         </p:spPr>
         <p:txBody>
-          <a:bodyPr xmlns:a="http://schemas.openxmlformats.org/drawingml/2006/main" lIns="0" tIns="0" rIns="0" bIns="0"/>
-          <a:lstStyle xmlns:a="http://schemas.openxmlformats.org/drawingml/2006/main">
+          <a:bodyPr lIns="0" tIns="0" rIns="0" bIns="0"/>
+          <a:lstStyle>
             <a:defPPr>
               <a:defRPr sz="2100" b="0">
                 <a:solidFill>
@@ -16949,7 +16949,7 @@
               </a:defRPr>
             </a:lvl9pPr>
           </a:lstStyle>
-          <a:p xmlns:a="http://schemas.openxmlformats.org/drawingml/2006/main">
+          <a:p>
             <a:pPr>
               <a:defRPr sz="2100" b="0">
                 <a:solidFill>
@@ -16977,33 +16977,33 @@
       <p:sp>
         <p:nvSpPr>
           <p:cNvPr id="6" name="">
-            <a:extLst xmlns:a="http://schemas.openxmlformats.org/drawingml/2006/main">
+            <a:extLst>
               <a:ext uri="{FF2B5EF4-FFF2-40B4-BE49-F238E27FC236}">
-                <a16:creationId xmlns:a16="http://schemas.microsoft.com/office/drawing/2014/main" id="{61A5F703-5123-4FB2-AF1A-8E0A28D7EBCE}"/>
+                <ns2:creationId id="{61A5F703-5123-4FB2-AF1A-8E0A28D7EBCE}"/>
               </a:ext>
             </a:extLst>
           </p:cNvPr>
           <p:cNvSpPr>
-            <a:spLocks xmlns:a="http://schemas.openxmlformats.org/drawingml/2006/main" noGrp="1"/>
+            <a:spLocks noGrp="1"/>
           </p:cNvSpPr>
           <p:nvPr/>
         </p:nvSpPr>
         <p:spPr>
-          <a:xfrm xmlns:a="http://schemas.openxmlformats.org/drawingml/2006/main">
+          <a:xfrm>
             <a:off x="5429250" y="3514725"/>
             <a:ext cx="6076950" cy="428625"/>
           </a:xfrm>
-          <a:prstGeom xmlns:a="http://schemas.openxmlformats.org/drawingml/2006/main" prst="rect">
+          <a:prstGeom prst="rect">
             <a:avLst/>
           </a:prstGeom>
-          <a:noFill xmlns:a="http://schemas.openxmlformats.org/drawingml/2006/main"/>
-          <a:ln xmlns:a="http://schemas.openxmlformats.org/drawingml/2006/main" w="0">
+          <a:noFill/>
+          <a:ln w="0">
             <a:noFill/>
           </a:ln>
         </p:spPr>
         <p:txBody>
-          <a:bodyPr xmlns:a="http://schemas.openxmlformats.org/drawingml/2006/main" lIns="0" tIns="0" rIns="0" bIns="0"/>
-          <a:lstStyle xmlns:a="http://schemas.openxmlformats.org/drawingml/2006/main">
+          <a:bodyPr lIns="0" tIns="0" rIns="0" bIns="0"/>
+          <a:lstStyle>
             <a:defPPr>
               <a:defRPr sz="2175" b="1">
                 <a:solidFill>
@@ -17105,7 +17105,7 @@
               </a:defRPr>
             </a:lvl9pPr>
           </a:lstStyle>
-          <a:p xmlns:a="http://schemas.openxmlformats.org/drawingml/2006/main">
+          <a:p>
             <a:pPr>
               <a:defRPr sz="2175" b="1">
                 <a:solidFill>
@@ -17133,33 +17133,33 @@
       <p:sp>
         <p:nvSpPr>
           <p:cNvPr id="7" name="">
-            <a:extLst xmlns:a="http://schemas.openxmlformats.org/drawingml/2006/main">
+            <a:extLst>
               <a:ext uri="{FF2B5EF4-FFF2-40B4-BE49-F238E27FC236}">
-                <a16:creationId xmlns:a16="http://schemas.microsoft.com/office/drawing/2014/main" id="{6AA65490-C24E-4014-8D2D-D0138C729FC2}"/>
+                <ns2:creationId id="{6AA65490-C24E-4014-8D2D-D0138C729FC2}"/>
               </a:ext>
             </a:extLst>
           </p:cNvPr>
           <p:cNvSpPr>
-            <a:spLocks xmlns:a="http://schemas.openxmlformats.org/drawingml/2006/main" noGrp="1"/>
+            <a:spLocks noGrp="1"/>
           </p:cNvSpPr>
           <p:nvPr/>
         </p:nvSpPr>
         <p:spPr>
-          <a:xfrm xmlns:a="http://schemas.openxmlformats.org/drawingml/2006/main">
+          <a:xfrm>
             <a:off x="5429250" y="3990975"/>
             <a:ext cx="6076950" cy="1428750"/>
           </a:xfrm>
-          <a:prstGeom xmlns:a="http://schemas.openxmlformats.org/drawingml/2006/main" prst="rect">
+          <a:prstGeom prst="rect">
             <a:avLst/>
           </a:prstGeom>
-          <a:noFill xmlns:a="http://schemas.openxmlformats.org/drawingml/2006/main"/>
-          <a:ln xmlns:a="http://schemas.openxmlformats.org/drawingml/2006/main" w="0">
+          <a:noFill/>
+          <a:ln w="0">
             <a:noFill/>
           </a:ln>
         </p:spPr>
         <p:txBody>
-          <a:bodyPr xmlns:a="http://schemas.openxmlformats.org/drawingml/2006/main" lIns="0" tIns="0" rIns="0" bIns="0"/>
-          <a:lstStyle xmlns:a="http://schemas.openxmlformats.org/drawingml/2006/main">
+          <a:bodyPr lIns="0" tIns="0" rIns="0" bIns="0"/>
+          <a:lstStyle>
             <a:defPPr>
               <a:defRPr sz="2100" b="0">
                 <a:solidFill>
@@ -17261,7 +17261,7 @@
               </a:defRPr>
             </a:lvl9pPr>
           </a:lstStyle>
-          <a:p xmlns:a="http://schemas.openxmlformats.org/drawingml/2006/main">
+          <a:p>
             <a:pPr>
               <a:defRPr sz="2100" b="0">
                 <a:solidFill>
@@ -17289,33 +17289,33 @@
       <p:sp>
         <p:nvSpPr>
           <p:cNvPr id="8" name="">
-            <a:extLst xmlns:a="http://schemas.openxmlformats.org/drawingml/2006/main">
+            <a:extLst>
               <a:ext uri="{FF2B5EF4-FFF2-40B4-BE49-F238E27FC236}">
-                <a16:creationId xmlns:a16="http://schemas.microsoft.com/office/drawing/2014/main" id="{9D81BB36-B095-4D9A-AE5B-D8F8DF3534C5}"/>
+                <ns2:creationId id="{9D81BB36-B095-4D9A-AE5B-D8F8DF3534C5}"/>
               </a:ext>
             </a:extLst>
           </p:cNvPr>
           <p:cNvSpPr>
-            <a:spLocks xmlns:a="http://schemas.openxmlformats.org/drawingml/2006/main" noGrp="1"/>
+            <a:spLocks noGrp="1"/>
           </p:cNvSpPr>
           <p:nvPr/>
         </p:nvSpPr>
         <p:spPr>
-          <a:xfrm xmlns:a="http://schemas.openxmlformats.org/drawingml/2006/main">
+          <a:xfrm>
             <a:off x="685800" y="5991225"/>
             <a:ext cx="10820400" cy="381000"/>
           </a:xfrm>
-          <a:prstGeom xmlns:a="http://schemas.openxmlformats.org/drawingml/2006/main" prst="rect">
+          <a:prstGeom prst="rect">
             <a:avLst/>
           </a:prstGeom>
-          <a:noFill xmlns:a="http://schemas.openxmlformats.org/drawingml/2006/main"/>
-          <a:ln xmlns:a="http://schemas.openxmlformats.org/drawingml/2006/main" w="0">
+          <a:noFill/>
+          <a:ln w="0">
             <a:noFill/>
           </a:ln>
         </p:spPr>
         <p:txBody>
-          <a:bodyPr xmlns:a="http://schemas.openxmlformats.org/drawingml/2006/main" lIns="0" tIns="0" rIns="0" bIns="0"/>
-          <a:lstStyle xmlns:a="http://schemas.openxmlformats.org/drawingml/2006/main">
+          <a:bodyPr lIns="0" tIns="0" rIns="0" bIns="0"/>
+          <a:lstStyle>
             <a:defPPr>
               <a:defRPr sz="1800" b="0">
                 <a:solidFill>
@@ -17417,7 +17417,7 @@
               </a:defRPr>
             </a:lvl9pPr>
           </a:lstStyle>
-          <a:p xmlns:a="http://schemas.openxmlformats.org/drawingml/2006/main">
+          <a:p>
             <a:pPr>
               <a:defRPr sz="1800" b="0">
                 <a:solidFill>
@@ -17438,6 +17438,319 @@
                 <a:cs typeface="Arial"/>
               </a:rPr>
               <a:t>CSV limits: 2 MB and 500 rows. Blank or invalid rows keep a visible status.</a:t>
+            </a:r>
+          </a:p>
+        </p:txBody>
+      </p:sp>
+      <p:sp>
+        <p:nvSpPr>
+          <p:cNvPr id="10" name="">
+            <a:extLst>
+              <a:ext uri="{FF2B5EF4-FFF2-40B4-BE49-F238E27FC236}">
+                <ns2:creationId id="{DF889820-3FAE-44C7-8700-F2E05AD309BE}"/>
+              </a:ext>
+            </a:extLst>
+          </p:cNvPr>
+          <p:cNvSpPr>
+            <a:spLocks noGrp="1"/>
+          </p:cNvSpPr>
+          <p:nvPr/>
+        </p:nvSpPr>
+        <p:spPr>
+          <a:xfrm>
+            <a:off x="5429250" y="5029200"/>
+            <a:ext cx="6076950" cy="361950"/>
+          </a:xfrm>
+          <a:prstGeom prst="rect">
+            <a:avLst/>
+          </a:prstGeom>
+          <a:noFill/>
+          <a:ln w="0">
+            <a:noFill/>
+          </a:ln>
+        </p:spPr>
+        <p:txBody>
+          <a:bodyPr lIns="0" tIns="0" rIns="0" bIns="0"/>
+          <a:lstStyle>
+            <a:defPPr>
+              <a:defRPr sz="1950" b="1">
+                <a:solidFill>
+                  <a:srgbClr val="007C83"/>
+                </a:solidFill>
+                <a:latin typeface="Arial"/>
+                <a:ea typeface="Arial"/>
+                <a:cs typeface="Arial"/>
+              </a:defRPr>
+            </a:defPPr>
+            <a:lvl1pPr>
+              <a:defRPr sz="1950" b="1">
+                <a:solidFill>
+                  <a:srgbClr val="007C83"/>
+                </a:solidFill>
+                <a:latin typeface="Arial"/>
+                <a:ea typeface="Arial"/>
+                <a:cs typeface="Arial"/>
+              </a:defRPr>
+            </a:lvl1pPr>
+            <a:lvl2pPr>
+              <a:defRPr sz="1950" b="1">
+                <a:solidFill>
+                  <a:srgbClr val="007C83"/>
+                </a:solidFill>
+                <a:latin typeface="Arial"/>
+                <a:ea typeface="Arial"/>
+                <a:cs typeface="Arial"/>
+              </a:defRPr>
+            </a:lvl2pPr>
+            <a:lvl3pPr>
+              <a:defRPr sz="1950" b="1">
+                <a:solidFill>
+                  <a:srgbClr val="007C83"/>
+                </a:solidFill>
+                <a:latin typeface="Arial"/>
+                <a:ea typeface="Arial"/>
+                <a:cs typeface="Arial"/>
+              </a:defRPr>
+            </a:lvl3pPr>
+            <a:lvl4pPr>
+              <a:defRPr sz="1950" b="1">
+                <a:solidFill>
+                  <a:srgbClr val="007C83"/>
+                </a:solidFill>
+                <a:latin typeface="Arial"/>
+                <a:ea typeface="Arial"/>
+                <a:cs typeface="Arial"/>
+              </a:defRPr>
+            </a:lvl4pPr>
+            <a:lvl5pPr>
+              <a:defRPr sz="1950" b="1">
+                <a:solidFill>
+                  <a:srgbClr val="007C83"/>
+                </a:solidFill>
+                <a:latin typeface="Arial"/>
+                <a:ea typeface="Arial"/>
+                <a:cs typeface="Arial"/>
+              </a:defRPr>
+            </a:lvl5pPr>
+            <a:lvl6pPr>
+              <a:defRPr sz="1950" b="1">
+                <a:solidFill>
+                  <a:srgbClr val="007C83"/>
+                </a:solidFill>
+                <a:latin typeface="Arial"/>
+                <a:ea typeface="Arial"/>
+                <a:cs typeface="Arial"/>
+              </a:defRPr>
+            </a:lvl6pPr>
+            <a:lvl7pPr>
+              <a:defRPr sz="1950" b="1">
+                <a:solidFill>
+                  <a:srgbClr val="007C83"/>
+                </a:solidFill>
+                <a:latin typeface="Arial"/>
+                <a:ea typeface="Arial"/>
+                <a:cs typeface="Arial"/>
+              </a:defRPr>
+            </a:lvl7pPr>
+            <a:lvl8pPr>
+              <a:defRPr sz="1950" b="1">
+                <a:solidFill>
+                  <a:srgbClr val="007C83"/>
+                </a:solidFill>
+                <a:latin typeface="Arial"/>
+                <a:ea typeface="Arial"/>
+                <a:cs typeface="Arial"/>
+              </a:defRPr>
+            </a:lvl8pPr>
+            <a:lvl9pPr>
+              <a:defRPr sz="1950" b="1">
+                <a:solidFill>
+                  <a:srgbClr val="007C83"/>
+                </a:solidFill>
+                <a:latin typeface="Arial"/>
+                <a:ea typeface="Arial"/>
+                <a:cs typeface="Arial"/>
+              </a:defRPr>
+            </a:lvl9pPr>
+          </a:lstStyle>
+          <a:p>
+            <a:pPr>
+              <a:defRPr sz="1950" b="1">
+                <a:solidFill>
+                  <a:srgbClr val="007C83"/>
+                </a:solidFill>
+                <a:latin typeface="Arial"/>
+                <a:ea typeface="Arial"/>
+                <a:cs typeface="Arial"/>
+              </a:defRPr>
+            </a:pPr>
+            <a:r>
+              <a:rPr sz="1950" b="1">
+                <a:solidFill>
+                  <a:srgbClr val="007C83"/>
+                </a:solidFill>
+                <a:latin typeface="Arial"/>
+                <a:ea typeface="Arial"/>
+                <a:cs typeface="Arial"/>
+              </a:rPr>
+              <a:t>Live app</a:t>
+            </a:r>
+          </a:p>
+        </p:txBody>
+      </p:sp>
+      <p:sp>
+        <p:nvSpPr>
+          <p:cNvPr id="11" name="">
+            <a:extLst>
+              <a:ext uri="{FF2B5EF4-FFF2-40B4-BE49-F238E27FC236}">
+                <ns2:creationId id="{91CB5954-A4D4-49F0-875C-E45F6207C7E7}"/>
+              </a:ext>
+            </a:extLst>
+          </p:cNvPr>
+          <p:cNvSpPr>
+            <a:spLocks noGrp="1"/>
+          </p:cNvSpPr>
+          <p:nvPr/>
+        </p:nvSpPr>
+        <p:spPr>
+          <a:xfrm>
+            <a:off x="5429250" y="5410200"/>
+            <a:ext cx="6076950" cy="419100"/>
+          </a:xfrm>
+          <a:prstGeom prst="rect">
+            <a:avLst/>
+          </a:prstGeom>
+          <a:noFill/>
+          <a:ln w="0">
+            <a:noFill/>
+          </a:ln>
+        </p:spPr>
+        <p:txBody>
+          <a:bodyPr lIns="0" tIns="0" rIns="0" bIns="0"/>
+          <a:lstStyle>
+            <a:defPPr>
+              <a:defRPr sz="1800" b="0">
+                <a:solidFill>
+                  <a:srgbClr val="172E40"/>
+                </a:solidFill>
+                <a:latin typeface="Arial"/>
+                <a:ea typeface="Arial"/>
+                <a:cs typeface="Arial"/>
+              </a:defRPr>
+            </a:defPPr>
+            <a:lvl1pPr>
+              <a:defRPr sz="1800" b="0">
+                <a:solidFill>
+                  <a:srgbClr val="172E40"/>
+                </a:solidFill>
+                <a:latin typeface="Arial"/>
+                <a:ea typeface="Arial"/>
+                <a:cs typeface="Arial"/>
+              </a:defRPr>
+            </a:lvl1pPr>
+            <a:lvl2pPr>
+              <a:defRPr sz="1800" b="0">
+                <a:solidFill>
+                  <a:srgbClr val="172E40"/>
+                </a:solidFill>
+                <a:latin typeface="Arial"/>
+                <a:ea typeface="Arial"/>
+                <a:cs typeface="Arial"/>
+              </a:defRPr>
+            </a:lvl2pPr>
+            <a:lvl3pPr>
+              <a:defRPr sz="1800" b="0">
+                <a:solidFill>
+                  <a:srgbClr val="172E40"/>
+                </a:solidFill>
+                <a:latin typeface="Arial"/>
+                <a:ea typeface="Arial"/>
+                <a:cs typeface="Arial"/>
+              </a:defRPr>
+            </a:lvl3pPr>
+            <a:lvl4pPr>
+              <a:defRPr sz="1800" b="0">
+                <a:solidFill>
+                  <a:srgbClr val="172E40"/>
+                </a:solidFill>
+                <a:latin typeface="Arial"/>
+                <a:ea typeface="Arial"/>
+                <a:cs typeface="Arial"/>
+              </a:defRPr>
+            </a:lvl4pPr>
+            <a:lvl5pPr>
+              <a:defRPr sz="1800" b="0">
+                <a:solidFill>
+                  <a:srgbClr val="172E40"/>
+                </a:solidFill>
+                <a:latin typeface="Arial"/>
+                <a:ea typeface="Arial"/>
+                <a:cs typeface="Arial"/>
+              </a:defRPr>
+            </a:lvl5pPr>
+            <a:lvl6pPr>
+              <a:defRPr sz="1800" b="0">
+                <a:solidFill>
+                  <a:srgbClr val="172E40"/>
+                </a:solidFill>
+                <a:latin typeface="Arial"/>
+                <a:ea typeface="Arial"/>
+                <a:cs typeface="Arial"/>
+              </a:defRPr>
+            </a:lvl6pPr>
+            <a:lvl7pPr>
+              <a:defRPr sz="1800" b="0">
+                <a:solidFill>
+                  <a:srgbClr val="172E40"/>
+                </a:solidFill>
+                <a:latin typeface="Arial"/>
+                <a:ea typeface="Arial"/>
+                <a:cs typeface="Arial"/>
+              </a:defRPr>
+            </a:lvl7pPr>
+            <a:lvl8pPr>
+              <a:defRPr sz="1800" b="0">
+                <a:solidFill>
+                  <a:srgbClr val="172E40"/>
+                </a:solidFill>
+                <a:latin typeface="Arial"/>
+                <a:ea typeface="Arial"/>
+                <a:cs typeface="Arial"/>
+              </a:defRPr>
+            </a:lvl8pPr>
+            <a:lvl9pPr>
+              <a:defRPr sz="1800" b="0">
+                <a:solidFill>
+                  <a:srgbClr val="172E40"/>
+                </a:solidFill>
+                <a:latin typeface="Arial"/>
+                <a:ea typeface="Arial"/>
+                <a:cs typeface="Arial"/>
+              </a:defRPr>
+            </a:lvl9pPr>
+          </a:lstStyle>
+          <a:p>
+            <a:pPr>
+              <a:defRPr sz="1800" b="0">
+                <a:solidFill>
+                  <a:srgbClr val="172E40"/>
+                </a:solidFill>
+                <a:latin typeface="Arial"/>
+                <a:ea typeface="Arial"/>
+                <a:cs typeface="Arial"/>
+              </a:defRPr>
+            </a:pPr>
+            <a:r>
+              <a:rPr sz="1800" b="0">
+                <a:solidFill>
+                  <a:srgbClr val="172E40"/>
+                </a:solidFill>
+                <a:latin typeface="Arial"/>
+                <a:ea typeface="Arial"/>
+                <a:cs typeface="Arial"/>
+                <a:hlinkClick r:id="rId1"/>
+              </a:rPr>
+              <a:t>financial-sentiment-akshatog.streamlit.app</a:t>
             </a:r>
           </a:p>
         </p:txBody>
@@ -17445,7 +17758,7 @@
     </p:spTree>
     <p:extLst>
       <p:ext uri="{BB962C8B-B14F-4D97-AF65-F5344CB8AC3E}">
-        <p14:creationId xmlns:p14="http://schemas.microsoft.com/office/powerpoint/2010/main" val="167810932"/>
+        <ns4:creationId val="167810932"/>
       </p:ext>
     </p:extLst>
   </p:cSld>

</xml_diff>